<commit_message>
feat: 联网动效素材能力 —— fetch_assets.py + make_motion.py
- fetch_assets.py: Mixkit 免费商用视频搜索/直链下载（重试/25MB 上限），
  许可自动记录到 assets/license.json 随 deck 存档；支持直链模式
- make_motion.py: 由 theme 配色本地生成无缝循环动效 GIF（漂移光斑氛围层，
  正弦往返保证首尾无缝，~1MB，零网络/零积分兜底）
- 嵌入规范: 视频 addMedia / GIF addImage 置于最底层，其上压暗蒙版再放文字；
  纪律: 仅封面/章节/收束氛围位，内容页禁用，交付列明来源与许可
- E2E: premium-st2 封面接入 GIF 动效层；effects-showcase 新增 p9 视频素材页
  （内嵌 Mixkit mp4 3.5MB，QA 通过，zip 结构验证 mp4×1 gif×1）
</commit_message>
<xml_diff>
--- a/examples/premium-st2/星尘ST2-发布会.pptx
+++ b/examples/premium-st2/星尘ST2-发布会.pptx
@@ -1683,9 +1683,61 @@
           <a:chExt cx="0" cy="0"/>
         </a:xfrm>
       </p:grpSpPr>
-      <p:sp>
-        <p:nvSpPr>
-          <p:cNvPr id="2" name="Shape 0"/>
+      <p:pic>
+        <p:nvPicPr>
+          <p:cNvPr id="2" name="Image 0" descr="assets/motion-bg.gif">    </p:cNvPr>
+          <p:cNvPicPr>
+            <a:picLocks noChangeAspect="1"/>
+          </p:cNvPicPr>
+          <p:nvPr/>
+        </p:nvPicPr>
+        <p:blipFill>
+          <a:blip r:embed="rId2">
+            <a:alphaModFix amt="58000"/>
+          </a:blip>
+          <a:stretch>
+            <a:fillRect/>
+          </a:stretch>
+        </p:blipFill>
+        <p:spPr>
+          <a:xfrm>
+            <a:off x="0" y="0"/>
+            <a:ext cx="12188952" cy="6858000"/>
+          </a:xfrm>
+          <a:prstGeom prst="rect">
+            <a:avLst/>
+          </a:prstGeom>
+        </p:spPr>
+      </p:pic>
+      <p:sp>
+        <p:nvSpPr>
+          <p:cNvPr id="3" name="Shape 0"/>
+          <p:cNvSpPr/>
+          <p:nvPr/>
+        </p:nvSpPr>
+        <p:spPr>
+          <a:xfrm>
+            <a:off x="0" y="0"/>
+            <a:ext cx="12188952" cy="6858000"/>
+          </a:xfrm>
+          <a:prstGeom prst="rect">
+            <a:avLst/>
+          </a:prstGeom>
+          <a:solidFill>
+            <a:srgbClr val="141210">
+              <a:alpha val="58000"/>
+            </a:srgbClr>
+          </a:solidFill>
+          <a:ln/>
+        </p:spPr>
+        <p:txBody>
+          <a:bodyPr/>
+          <a:p/>
+        </p:txBody>
+      </p:sp>
+      <p:sp>
+        <p:nvSpPr>
+          <p:cNvPr id="4" name="Shape 1"/>
           <p:cNvSpPr/>
           <p:nvPr/>
         </p:nvSpPr>
@@ -1718,14 +1770,14 @@
       </p:sp>
       <p:pic>
         <p:nvPicPr>
-          <p:cNvPr id="3" name="Image 0" descr="assets/glow.png">    </p:cNvPr>
+          <p:cNvPr id="5" name="Image 1" descr="assets/glow.png">    </p:cNvPr>
           <p:cNvPicPr>
             <a:picLocks noChangeAspect="1"/>
           </p:cNvPicPr>
           <p:nvPr/>
         </p:nvPicPr>
         <p:blipFill>
-          <a:blip r:embed="rId2">
+          <a:blip r:embed="rId3">
             <a:alphaModFix amt="45000"/>
           </a:blip>
           <a:stretch>
@@ -1744,7 +1796,7 @@
       </p:pic>
       <p:sp>
         <p:nvSpPr>
-          <p:cNvPr id="4" name="Text 1"/>
+          <p:cNvPr id="6" name="Text 2"/>
           <p:cNvSpPr/>
           <p:nvPr/>
         </p:nvSpPr>
@@ -1783,7 +1835,7 @@
       </p:sp>
       <p:sp>
         <p:nvSpPr>
-          <p:cNvPr id="5" name="Text 2"/>
+          <p:cNvPr id="7" name="Text 3"/>
           <p:cNvSpPr/>
           <p:nvPr/>
         </p:nvSpPr>
@@ -1822,7 +1874,7 @@
       </p:sp>
       <p:sp>
         <p:nvSpPr>
-          <p:cNvPr id="6" name="Text 3"/>
+          <p:cNvPr id="8" name="Text 4"/>
           <p:cNvSpPr/>
           <p:nvPr/>
         </p:nvSpPr>
@@ -1904,7 +1956,7 @@
                                           </p:stCondLst>
                                         </p:cTn>
                                         <p:tgtEl>
-                                          <p:spTgt spid="3"/>
+                                          <p:spTgt spid="2"/>
                                         </p:tgtEl>
                                         <p:attrNameLst>
                                           <p:attrName>style.visibility</p:attrName>
@@ -1918,7 +1970,7 @@
                                       <p:cBhvr>
                                         <p:cTn id="6" dur="790"/>
                                         <p:tgtEl>
-                                          <p:spTgt spid="3"/>
+                                          <p:spTgt spid="2"/>
                                         </p:tgtEl>
                                       </p:cBhvr>
                                     </p:animEffect>
@@ -1931,7 +1983,139 @@
                         <p:par>
                           <p:cTn id="7" fill="hold">
                             <p:stCondLst>
-                              <p:cond delay="736"/>
+                              <p:cond delay="200"/>
+                            </p:stCondLst>
+                            <p:childTnLst>
+                              <p:par>
+                                <p:cTn presetID="10" presetClass="entr" presetSubtype="0" fill="hold" grpId="0" nodeType="afterEffect">
+                                  <p:stCondLst>
+                                    <p:cond delay="0"/>
+                                  </p:stCondLst>
+                                  <p:childTnLst>
+                                    <p:set>
+                                      <p:cBhvr>
+                                        <p:cTn id="8" dur="1" fill="hold">
+                                          <p:stCondLst>
+                                            <p:cond delay="0"/>
+                                          </p:stCondLst>
+                                        </p:cTn>
+                                        <p:tgtEl>
+                                          <p:spTgt spid="3"/>
+                                        </p:tgtEl>
+                                        <p:attrNameLst>
+                                          <p:attrName>style.visibility</p:attrName>
+                                        </p:attrNameLst>
+                                      </p:cBhvr>
+                                      <p:to>
+                                        <p:strVal val="visible"/>
+                                      </p:to>
+                                    </p:set>
+                                    <p:animEffect transition="in" filter="fade">
+                                      <p:cBhvr>
+                                        <p:cTn id="9" dur="650"/>
+                                        <p:tgtEl>
+                                          <p:spTgt spid="3"/>
+                                        </p:tgtEl>
+                                      </p:cBhvr>
+                                    </p:animEffect>
+                                  </p:childTnLst>
+                                </p:cTn>
+                              </p:par>
+                            </p:childTnLst>
+                          </p:cTn>
+                        </p:par>
+                        <p:par>
+                          <p:cTn id="10" fill="hold">
+                            <p:stCondLst>
+                              <p:cond delay="400"/>
+                            </p:stCondLst>
+                            <p:childTnLst>
+                              <p:par>
+                                <p:cTn presetID="10" presetClass="entr" presetSubtype="0" fill="hold" grpId="0" nodeType="afterEffect">
+                                  <p:stCondLst>
+                                    <p:cond delay="0"/>
+                                  </p:stCondLst>
+                                  <p:childTnLst>
+                                    <p:set>
+                                      <p:cBhvr>
+                                        <p:cTn id="11" dur="1" fill="hold">
+                                          <p:stCondLst>
+                                            <p:cond delay="0"/>
+                                          </p:stCondLst>
+                                        </p:cTn>
+                                        <p:tgtEl>
+                                          <p:spTgt spid="5"/>
+                                        </p:tgtEl>
+                                        <p:attrNameLst>
+                                          <p:attrName>style.visibility</p:attrName>
+                                        </p:attrNameLst>
+                                      </p:cBhvr>
+                                      <p:to>
+                                        <p:strVal val="visible"/>
+                                      </p:to>
+                                    </p:set>
+                                    <p:animEffect transition="in" filter="fade">
+                                      <p:cBhvr>
+                                        <p:cTn id="12" dur="790"/>
+                                        <p:tgtEl>
+                                          <p:spTgt spid="5"/>
+                                        </p:tgtEl>
+                                      </p:cBhvr>
+                                    </p:animEffect>
+                                  </p:childTnLst>
+                                </p:cTn>
+                              </p:par>
+                            </p:childTnLst>
+                          </p:cTn>
+                        </p:par>
+                        <p:par>
+                          <p:cTn id="13" fill="hold">
+                            <p:stCondLst>
+                              <p:cond delay="600"/>
+                            </p:stCondLst>
+                            <p:childTnLst>
+                              <p:par>
+                                <p:cTn presetID="10" presetClass="entr" presetSubtype="0" fill="hold" grpId="0" nodeType="afterEffect">
+                                  <p:stCondLst>
+                                    <p:cond delay="0"/>
+                                  </p:stCondLst>
+                                  <p:childTnLst>
+                                    <p:set>
+                                      <p:cBhvr>
+                                        <p:cTn id="14" dur="1" fill="hold">
+                                          <p:stCondLst>
+                                            <p:cond delay="0"/>
+                                          </p:stCondLst>
+                                        </p:cTn>
+                                        <p:tgtEl>
+                                          <p:spTgt spid="5"/>
+                                        </p:tgtEl>
+                                        <p:attrNameLst>
+                                          <p:attrName>style.visibility</p:attrName>
+                                        </p:attrNameLst>
+                                      </p:cBhvr>
+                                      <p:to>
+                                        <p:strVal val="visible"/>
+                                      </p:to>
+                                    </p:set>
+                                    <p:animEffect transition="in" filter="fade">
+                                      <p:cBhvr>
+                                        <p:cTn id="15" dur="650"/>
+                                        <p:tgtEl>
+                                          <p:spTgt spid="5"/>
+                                        </p:tgtEl>
+                                      </p:cBhvr>
+                                    </p:animEffect>
+                                  </p:childTnLst>
+                                </p:cTn>
+                              </p:par>
+                            </p:childTnLst>
+                          </p:cTn>
+                        </p:par>
+                        <p:par>
+                          <p:cTn id="16" fill="hold">
+                            <p:stCondLst>
+                              <p:cond delay="1340"/>
                             </p:stCondLst>
                             <p:childTnLst>
                               <p:par>
@@ -1942,13 +2126,13 @@
                                   <p:childTnLst>
                                     <p:set>
                                       <p:cBhvr>
-                                        <p:cTn id="8" dur="1" fill="hold">
+                                        <p:cTn id="17" dur="1" fill="hold">
                                           <p:stCondLst>
                                             <p:cond delay="0"/>
                                           </p:stCondLst>
                                         </p:cTn>
                                         <p:tgtEl>
-                                          <p:spTgt spid="4"/>
+                                          <p:spTgt spid="6"/>
                                         </p:tgtEl>
                                         <p:attrNameLst>
                                           <p:attrName>style.visibility</p:attrName>
@@ -1960,17 +2144,17 @@
                                     </p:set>
                                     <p:animEffect transition="in" filter="fade">
                                       <p:cBhvr>
-                                        <p:cTn id="9" dur="790"/>
-                                        <p:tgtEl>
-                                          <p:spTgt spid="4"/>
+                                        <p:cTn id="18" dur="790"/>
+                                        <p:tgtEl>
+                                          <p:spTgt spid="6"/>
                                         </p:tgtEl>
                                       </p:cBhvr>
                                     </p:animEffect>
                                     <p:animScale>
                                       <p:cBhvr>
-                                        <p:cTn id="10" dur="790"/>
-                                        <p:tgtEl>
-                                          <p:spTgt spid="4"/>
+                                        <p:cTn id="19" dur="790"/>
+                                        <p:tgtEl>
+                                          <p:spTgt spid="6"/>
                                         </p:tgtEl>
                                       </p:cBhvr>
                                       <p:from x="55000" y="55000"/>
@@ -1983,9 +2167,9 @@
                           </p:cTn>
                         </p:par>
                         <p:par>
-                          <p:cTn id="11" fill="hold">
+                          <p:cTn id="20" fill="hold">
                             <p:stCondLst>
-                              <p:cond delay="1472"/>
+                              <p:cond delay="1540"/>
                             </p:stCondLst>
                             <p:childTnLst>
                               <p:par>
@@ -1996,13 +2180,13 @@
                                   <p:childTnLst>
                                     <p:set>
                                       <p:cBhvr>
-                                        <p:cTn id="12" dur="1" fill="hold">
+                                        <p:cTn id="21" dur="1" fill="hold">
                                           <p:stCondLst>
                                             <p:cond delay="0"/>
                                           </p:stCondLst>
                                         </p:cTn>
                                         <p:tgtEl>
-                                          <p:spTgt spid="5"/>
+                                          <p:spTgt spid="7"/>
                                         </p:tgtEl>
                                         <p:attrNameLst>
                                           <p:attrName>style.visibility</p:attrName>
@@ -2014,9 +2198,9 @@
                                     </p:set>
                                     <p:animEffect transition="in" filter="fade">
                                       <p:cBhvr>
-                                        <p:cTn id="13" dur="650"/>
-                                        <p:tgtEl>
-                                          <p:spTgt spid="5"/>
+                                        <p:cTn id="22" dur="650"/>
+                                        <p:tgtEl>
+                                          <p:spTgt spid="7"/>
                                         </p:tgtEl>
                                       </p:cBhvr>
                                     </p:animEffect>
@@ -2027,9 +2211,9 @@
                           </p:cTn>
                         </p:par>
                         <p:par>
-                          <p:cTn id="14" fill="hold">
+                          <p:cTn id="23" fill="hold">
                             <p:stCondLst>
-                              <p:cond delay="2208"/>
+                              <p:cond delay="1740"/>
                             </p:stCondLst>
                             <p:childTnLst>
                               <p:par>
@@ -2040,13 +2224,13 @@
                                   <p:childTnLst>
                                     <p:set>
                                       <p:cBhvr>
-                                        <p:cTn id="15" dur="1" fill="hold">
+                                        <p:cTn id="24" dur="1" fill="hold">
                                           <p:stCondLst>
                                             <p:cond delay="0"/>
                                           </p:stCondLst>
                                         </p:cTn>
                                         <p:tgtEl>
-                                          <p:spTgt spid="6"/>
+                                          <p:spTgt spid="8"/>
                                         </p:tgtEl>
                                         <p:attrNameLst>
                                           <p:attrName>style.visibility</p:attrName>
@@ -2058,9 +2242,9 @@
                                     </p:set>
                                     <p:animEffect transition="in" filter="fade">
                                       <p:cBhvr>
-                                        <p:cTn id="16" dur="650"/>
-                                        <p:tgtEl>
-                                          <p:spTgt spid="6"/>
+                                        <p:cTn id="25" dur="650"/>
+                                        <p:tgtEl>
+                                          <p:spTgt spid="8"/>
                                         </p:tgtEl>
                                       </p:cBhvr>
                                     </p:animEffect>
@@ -2095,10 +2279,12 @@
       </p:par>
     </p:tnLst>
     <p:bldLst>
+      <p:bldP spid="2" grpId="0"/>
       <p:bldP spid="3" grpId="0"/>
-      <p:bldP spid="4" grpId="0"/>
       <p:bldP spid="5" grpId="0"/>
       <p:bldP spid="6" grpId="0"/>
+      <p:bldP spid="7" grpId="0"/>
+      <p:bldP spid="8" grpId="0"/>
     </p:bldLst>
   </p:timing>
 </p:sld>
@@ -2285,7 +2471,7 @@
                         <p:par>
                           <p:cTn id="7" fill="hold">
                             <p:stCondLst>
-                              <p:cond delay="740"/>
+                              <p:cond delay="200"/>
                             </p:stCondLst>
                             <p:childTnLst>
                               <p:par>
@@ -2621,7 +2807,7 @@
                         <p:par>
                           <p:cTn id="8" fill="hold">
                             <p:stCondLst>
-                              <p:cond delay="740"/>
+                              <p:cond delay="200"/>
                             </p:stCondLst>
                             <p:childTnLst>
                               <p:par>
@@ -3357,50 +3543,6 @@
                             </p:stCondLst>
                             <p:childTnLst>
                               <p:par>
-                                <p:cTn presetID="10" presetClass="entr" presetSubtype="0" fill="hold" grpId="0" nodeType="afterEffect">
-                                  <p:stCondLst>
-                                    <p:cond delay="0"/>
-                                  </p:stCondLst>
-                                  <p:childTnLst>
-                                    <p:set>
-                                      <p:cBhvr>
-                                        <p:cTn id="9" dur="1" fill="hold">
-                                          <p:stCondLst>
-                                            <p:cond delay="0"/>
-                                          </p:stCondLst>
-                                        </p:cTn>
-                                        <p:tgtEl>
-                                          <p:spTgt spid="3"/>
-                                        </p:tgtEl>
-                                        <p:attrNameLst>
-                                          <p:attrName>style.visibility</p:attrName>
-                                        </p:attrNameLst>
-                                      </p:cBhvr>
-                                      <p:to>
-                                        <p:strVal val="visible"/>
-                                      </p:to>
-                                    </p:set>
-                                    <p:animEffect transition="in" filter="fade">
-                                      <p:cBhvr>
-                                        <p:cTn id="10" dur="650"/>
-                                        <p:tgtEl>
-                                          <p:spTgt spid="3"/>
-                                        </p:tgtEl>
-                                      </p:cBhvr>
-                                    </p:animEffect>
-                                  </p:childTnLst>
-                                </p:cTn>
-                              </p:par>
-                            </p:childTnLst>
-                          </p:cTn>
-                        </p:par>
-                        <p:par>
-                          <p:cTn id="11" fill="hold">
-                            <p:stCondLst>
-                              <p:cond delay="940"/>
-                            </p:stCondLst>
-                            <p:childTnLst>
-                              <p:par>
                                 <p:cTn presetID="23" presetClass="entr" presetSubtype="16" fill="hold" grpId="0" nodeType="afterEffect">
                                   <p:stCondLst>
                                     <p:cond delay="0"/>
@@ -3408,7 +3550,7 @@
                                   <p:childTnLst>
                                     <p:set>
                                       <p:cBhvr>
-                                        <p:cTn id="12" dur="1" fill="hold">
+                                        <p:cTn id="9" dur="1" fill="hold">
                                           <p:stCondLst>
                                             <p:cond delay="0"/>
                                           </p:stCondLst>
@@ -3426,7 +3568,7 @@
                                     </p:set>
                                     <p:animEffect transition="in" filter="fade">
                                       <p:cBhvr>
-                                        <p:cTn id="13" dur="790"/>
+                                        <p:cTn id="10" dur="790"/>
                                         <p:tgtEl>
                                           <p:spTgt spid="5"/>
                                         </p:tgtEl>
@@ -3434,7 +3576,7 @@
                                     </p:animEffect>
                                     <p:animScale>
                                       <p:cBhvr>
-                                        <p:cTn id="14" dur="790"/>
+                                        <p:cTn id="11" dur="790"/>
                                         <p:tgtEl>
                                           <p:spTgt spid="5"/>
                                         </p:tgtEl>
@@ -3449,9 +3591,53 @@
                           </p:cTn>
                         </p:par>
                         <p:par>
+                          <p:cTn id="12" fill="hold">
+                            <p:stCondLst>
+                              <p:cond delay="400"/>
+                            </p:stCondLst>
+                            <p:childTnLst>
+                              <p:par>
+                                <p:cTn presetID="10" presetClass="entr" presetSubtype="0" fill="hold" grpId="0" nodeType="afterEffect">
+                                  <p:stCondLst>
+                                    <p:cond delay="0"/>
+                                  </p:stCondLst>
+                                  <p:childTnLst>
+                                    <p:set>
+                                      <p:cBhvr>
+                                        <p:cTn id="13" dur="1" fill="hold">
+                                          <p:stCondLst>
+                                            <p:cond delay="0"/>
+                                          </p:stCondLst>
+                                        </p:cTn>
+                                        <p:tgtEl>
+                                          <p:spTgt spid="3"/>
+                                        </p:tgtEl>
+                                        <p:attrNameLst>
+                                          <p:attrName>style.visibility</p:attrName>
+                                        </p:attrNameLst>
+                                      </p:cBhvr>
+                                      <p:to>
+                                        <p:strVal val="visible"/>
+                                      </p:to>
+                                    </p:set>
+                                    <p:animEffect transition="in" filter="fade">
+                                      <p:cBhvr>
+                                        <p:cTn id="14" dur="650"/>
+                                        <p:tgtEl>
+                                          <p:spTgt spid="3"/>
+                                        </p:tgtEl>
+                                      </p:cBhvr>
+                                    </p:animEffect>
+                                  </p:childTnLst>
+                                </p:cTn>
+                              </p:par>
+                            </p:childTnLst>
+                          </p:cTn>
+                        </p:par>
+                        <p:par>
                           <p:cTn id="15" fill="hold">
                             <p:stCondLst>
-                              <p:cond delay="1140"/>
+                              <p:cond delay="600"/>
                             </p:stCondLst>
                             <p:childTnLst>
                               <p:par>
@@ -3495,7 +3681,7 @@
                         <p:par>
                           <p:cTn id="18" fill="hold">
                             <p:stCondLst>
-                              <p:cond delay="1880"/>
+                              <p:cond delay="1340"/>
                             </p:stCondLst>
                             <p:childTnLst>
                               <p:par>
@@ -3549,7 +3735,7 @@
                         <p:par>
                           <p:cTn id="22" fill="hold">
                             <p:stCondLst>
-                              <p:cond delay="2080"/>
+                              <p:cond delay="1540"/>
                             </p:stCondLst>
                             <p:childTnLst>
                               <p:par>
@@ -3616,8 +3802,8 @@
     </p:tnLst>
     <p:bldLst>
       <p:bldP spid="2" grpId="0"/>
+      <p:bldP spid="5" grpId="0"/>
       <p:bldP spid="3" grpId="0"/>
-      <p:bldP spid="5" grpId="0"/>
       <p:bldP spid="6" grpId="0"/>
       <p:bldP spid="8" grpId="0"/>
       <p:bldP spid="9" grpId="0"/>
@@ -4043,7 +4229,7 @@
                             </p:stCondLst>
                             <p:childTnLst>
                               <p:par>
-                                <p:cTn presetID="23" presetClass="entr" presetSubtype="16" fill="hold" grpId="0" nodeType="afterEffect">
+                                <p:cTn presetID="10" presetClass="entr" presetSubtype="0" fill="hold" grpId="0" nodeType="afterEffect">
                                   <p:stCondLst>
                                     <p:cond delay="0"/>
                                   </p:stCondLst>
@@ -4056,7 +4242,7 @@
                                           </p:stCondLst>
                                         </p:cTn>
                                         <p:tgtEl>
-                                          <p:spTgt spid="4"/>
+                                          <p:spTgt spid="3"/>
                                         </p:tgtEl>
                                         <p:attrNameLst>
                                           <p:attrName>style.visibility</p:attrName>
@@ -4068,22 +4254,12 @@
                                     </p:set>
                                     <p:animEffect transition="in" filter="fade">
                                       <p:cBhvr>
-                                        <p:cTn id="10" dur="790"/>
-                                        <p:tgtEl>
-                                          <p:spTgt spid="4"/>
+                                        <p:cTn id="10" dur="650"/>
+                                        <p:tgtEl>
+                                          <p:spTgt spid="3"/>
                                         </p:tgtEl>
                                       </p:cBhvr>
                                     </p:animEffect>
-                                    <p:animScale>
-                                      <p:cBhvr>
-                                        <p:cTn id="11" dur="790"/>
-                                        <p:tgtEl>
-                                          <p:spTgt spid="4"/>
-                                        </p:tgtEl>
-                                      </p:cBhvr>
-                                      <p:from x="55000" y="55000"/>
-                                      <p:to x="100000" y="100000"/>
-                                    </p:animScale>
                                   </p:childTnLst>
                                 </p:cTn>
                               </p:par>
@@ -4091,7 +4267,7 @@
                           </p:cTn>
                         </p:par>
                         <p:par>
-                          <p:cTn id="12" fill="hold">
+                          <p:cTn id="11" fill="hold">
                             <p:stCondLst>
                               <p:cond delay="400"/>
                             </p:stCondLst>
@@ -4104,13 +4280,13 @@
                                   <p:childTnLst>
                                     <p:set>
                                       <p:cBhvr>
-                                        <p:cTn id="13" dur="1" fill="hold">
+                                        <p:cTn id="12" dur="1" fill="hold">
                                           <p:stCondLst>
                                             <p:cond delay="0"/>
                                           </p:stCondLst>
                                         </p:cTn>
                                         <p:tgtEl>
-                                          <p:spTgt spid="6"/>
+                                          <p:spTgt spid="4"/>
                                         </p:tgtEl>
                                         <p:attrNameLst>
                                           <p:attrName>style.visibility</p:attrName>
@@ -4122,17 +4298,17 @@
                                     </p:set>
                                     <p:animEffect transition="in" filter="fade">
                                       <p:cBhvr>
-                                        <p:cTn id="14" dur="790"/>
-                                        <p:tgtEl>
-                                          <p:spTgt spid="6"/>
+                                        <p:cTn id="13" dur="790"/>
+                                        <p:tgtEl>
+                                          <p:spTgt spid="4"/>
                                         </p:tgtEl>
                                       </p:cBhvr>
                                     </p:animEffect>
                                     <p:animScale>
                                       <p:cBhvr>
-                                        <p:cTn id="15" dur="790"/>
-                                        <p:tgtEl>
-                                          <p:spTgt spid="6"/>
+                                        <p:cTn id="14" dur="790"/>
+                                        <p:tgtEl>
+                                          <p:spTgt spid="4"/>
                                         </p:tgtEl>
                                       </p:cBhvr>
                                       <p:from x="55000" y="55000"/>
@@ -4145,26 +4321,26 @@
                           </p:cTn>
                         </p:par>
                         <p:par>
-                          <p:cTn id="16" fill="hold">
+                          <p:cTn id="15" fill="hold">
                             <p:stCondLst>
-                              <p:cond delay="1140"/>
+                              <p:cond delay="600"/>
                             </p:stCondLst>
                             <p:childTnLst>
                               <p:par>
-                                <p:cTn presetID="10" presetClass="entr" presetSubtype="0" fill="hold" grpId="0" nodeType="afterEffect">
+                                <p:cTn presetID="23" presetClass="entr" presetSubtype="16" fill="hold" grpId="0" nodeType="afterEffect">
                                   <p:stCondLst>
                                     <p:cond delay="0"/>
                                   </p:stCondLst>
                                   <p:childTnLst>
                                     <p:set>
                                       <p:cBhvr>
-                                        <p:cTn id="17" dur="1" fill="hold">
+                                        <p:cTn id="16" dur="1" fill="hold">
                                           <p:stCondLst>
                                             <p:cond delay="0"/>
                                           </p:stCondLst>
                                         </p:cTn>
                                         <p:tgtEl>
-                                          <p:spTgt spid="3"/>
+                                          <p:spTgt spid="6"/>
                                         </p:tgtEl>
                                         <p:attrNameLst>
                                           <p:attrName>style.visibility</p:attrName>
@@ -4176,12 +4352,22 @@
                                     </p:set>
                                     <p:animEffect transition="in" filter="fade">
                                       <p:cBhvr>
-                                        <p:cTn id="18" dur="650"/>
-                                        <p:tgtEl>
-                                          <p:spTgt spid="3"/>
+                                        <p:cTn id="17" dur="790"/>
+                                        <p:tgtEl>
+                                          <p:spTgt spid="6"/>
                                         </p:tgtEl>
                                       </p:cBhvr>
                                     </p:animEffect>
+                                    <p:animScale>
+                                      <p:cBhvr>
+                                        <p:cTn id="18" dur="790"/>
+                                        <p:tgtEl>
+                                          <p:spTgt spid="6"/>
+                                        </p:tgtEl>
+                                      </p:cBhvr>
+                                      <p:from x="55000" y="55000"/>
+                                      <p:to x="100000" y="100000"/>
+                                    </p:animScale>
                                   </p:childTnLst>
                                 </p:cTn>
                               </p:par>
@@ -4302,9 +4488,9 @@
     </p:tnLst>
     <p:bldLst>
       <p:bldP spid="2" grpId="0"/>
+      <p:bldP spid="3" grpId="0"/>
       <p:bldP spid="4" grpId="0"/>
       <p:bldP spid="6" grpId="0"/>
-      <p:bldP spid="3" grpId="0"/>
       <p:bldP spid="5" grpId="0"/>
       <p:bldP spid="7" grpId="0"/>
     </p:bldLst>
@@ -5118,7 +5304,7 @@
                         <p:par>
                           <p:cTn id="8" fill="hold">
                             <p:stCondLst>
-                              <p:cond delay="99"/>
+                              <p:cond delay="125"/>
                             </p:stCondLst>
                             <p:childTnLst>
                               <p:par>
@@ -5162,7 +5348,7 @@
                         <p:par>
                           <p:cTn id="11" fill="hold">
                             <p:stCondLst>
-                              <p:cond delay="198"/>
+                              <p:cond delay="250"/>
                             </p:stCondLst>
                             <p:childTnLst>
                               <p:par>
@@ -5179,7 +5365,7 @@
                                           </p:stCondLst>
                                         </p:cTn>
                                         <p:tgtEl>
-                                          <p:spTgt spid="7"/>
+                                          <p:spTgt spid="5"/>
                                         </p:tgtEl>
                                         <p:attrNameLst>
                                           <p:attrName>style.visibility</p:attrName>
@@ -5193,7 +5379,7 @@
                                       <p:cBhvr>
                                         <p:cTn id="13" dur="650"/>
                                         <p:tgtEl>
-                                          <p:spTgt spid="7"/>
+                                          <p:spTgt spid="5"/>
                                         </p:tgtEl>
                                       </p:cBhvr>
                                     </p:animEffect>
@@ -5206,7 +5392,7 @@
                         <p:par>
                           <p:cTn id="14" fill="hold">
                             <p:stCondLst>
-                              <p:cond delay="892"/>
+                              <p:cond delay="375"/>
                             </p:stCondLst>
                             <p:childTnLst>
                               <p:par>
@@ -5223,7 +5409,7 @@
                                           </p:stCondLst>
                                         </p:cTn>
                                         <p:tgtEl>
-                                          <p:spTgt spid="5"/>
+                                          <p:spTgt spid="7"/>
                                         </p:tgtEl>
                                         <p:attrNameLst>
                                           <p:attrName>style.visibility</p:attrName>
@@ -5237,7 +5423,7 @@
                                       <p:cBhvr>
                                         <p:cTn id="16" dur="650"/>
                                         <p:tgtEl>
-                                          <p:spTgt spid="5"/>
+                                          <p:spTgt spid="7"/>
                                         </p:tgtEl>
                                       </p:cBhvr>
                                     </p:animEffect>
@@ -5250,7 +5436,7 @@
                         <p:par>
                           <p:cTn id="17" fill="hold">
                             <p:stCondLst>
-                              <p:cond delay="991"/>
+                              <p:cond delay="1081"/>
                             </p:stCondLst>
                             <p:childTnLst>
                               <p:par>
@@ -5267,7 +5453,7 @@
                                           </p:stCondLst>
                                         </p:cTn>
                                         <p:tgtEl>
-                                          <p:spTgt spid="8"/>
+                                          <p:spTgt spid="10"/>
                                         </p:tgtEl>
                                         <p:attrNameLst>
                                           <p:attrName>style.visibility</p:attrName>
@@ -5281,7 +5467,7 @@
                                       <p:cBhvr>
                                         <p:cTn id="19" dur="650"/>
                                         <p:tgtEl>
-                                          <p:spTgt spid="8"/>
+                                          <p:spTgt spid="10"/>
                                         </p:tgtEl>
                                       </p:cBhvr>
                                     </p:animEffect>
@@ -5294,7 +5480,7 @@
                         <p:par>
                           <p:cTn id="20" fill="hold">
                             <p:stCondLst>
-                              <p:cond delay="1685"/>
+                              <p:cond delay="1206"/>
                             </p:stCondLst>
                             <p:childTnLst>
                               <p:par>
@@ -5311,7 +5497,7 @@
                                           </p:stCondLst>
                                         </p:cTn>
                                         <p:tgtEl>
-                                          <p:spTgt spid="10"/>
+                                          <p:spTgt spid="11"/>
                                         </p:tgtEl>
                                         <p:attrNameLst>
                                           <p:attrName>style.visibility</p:attrName>
@@ -5325,7 +5511,7 @@
                                       <p:cBhvr>
                                         <p:cTn id="22" dur="650"/>
                                         <p:tgtEl>
-                                          <p:spTgt spid="10"/>
+                                          <p:spTgt spid="11"/>
                                         </p:tgtEl>
                                       </p:cBhvr>
                                     </p:animEffect>
@@ -5338,7 +5524,7 @@
                         <p:par>
                           <p:cTn id="23" fill="hold">
                             <p:stCondLst>
-                              <p:cond delay="1784"/>
+                              <p:cond delay="1331"/>
                             </p:stCondLst>
                             <p:childTnLst>
                               <p:par>
@@ -5355,7 +5541,7 @@
                                           </p:stCondLst>
                                         </p:cTn>
                                         <p:tgtEl>
-                                          <p:spTgt spid="13"/>
+                                          <p:spTgt spid="8"/>
                                         </p:tgtEl>
                                         <p:attrNameLst>
                                           <p:attrName>style.visibility</p:attrName>
@@ -5369,7 +5555,7 @@
                                       <p:cBhvr>
                                         <p:cTn id="25" dur="650"/>
                                         <p:tgtEl>
-                                          <p:spTgt spid="13"/>
+                                          <p:spTgt spid="8"/>
                                         </p:tgtEl>
                                       </p:cBhvr>
                                     </p:animEffect>
@@ -5382,7 +5568,7 @@
                         <p:par>
                           <p:cTn id="26" fill="hold">
                             <p:stCondLst>
-                              <p:cond delay="2478"/>
+                              <p:cond delay="1456"/>
                             </p:stCondLst>
                             <p:childTnLst>
                               <p:par>
@@ -5399,7 +5585,7 @@
                                           </p:stCondLst>
                                         </p:cTn>
                                         <p:tgtEl>
-                                          <p:spTgt spid="3"/>
+                                          <p:spTgt spid="13"/>
                                         </p:tgtEl>
                                         <p:attrNameLst>
                                           <p:attrName>style.visibility</p:attrName>
@@ -5413,7 +5599,7 @@
                                       <p:cBhvr>
                                         <p:cTn id="28" dur="650"/>
                                         <p:tgtEl>
-                                          <p:spTgt spid="3"/>
+                                          <p:spTgt spid="13"/>
                                         </p:tgtEl>
                                       </p:cBhvr>
                                     </p:animEffect>
@@ -5426,7 +5612,7 @@
                         <p:par>
                           <p:cTn id="29" fill="hold">
                             <p:stCondLst>
-                              <p:cond delay="2577"/>
+                              <p:cond delay="2162"/>
                             </p:stCondLst>
                             <p:childTnLst>
                               <p:par>
@@ -5443,7 +5629,7 @@
                                           </p:stCondLst>
                                         </p:cTn>
                                         <p:tgtEl>
-                                          <p:spTgt spid="11"/>
+                                          <p:spTgt spid="3"/>
                                         </p:tgtEl>
                                         <p:attrNameLst>
                                           <p:attrName>style.visibility</p:attrName>
@@ -5457,7 +5643,7 @@
                                       <p:cBhvr>
                                         <p:cTn id="31" dur="650"/>
                                         <p:tgtEl>
-                                          <p:spTgt spid="11"/>
+                                          <p:spTgt spid="3"/>
                                         </p:tgtEl>
                                       </p:cBhvr>
                                     </p:animEffect>
@@ -5470,7 +5656,7 @@
                         <p:par>
                           <p:cTn id="32" fill="hold">
                             <p:stCondLst>
-                              <p:cond delay="2676"/>
+                              <p:cond delay="2287"/>
                             </p:stCondLst>
                             <p:childTnLst>
                               <p:par>
@@ -5487,7 +5673,7 @@
                                           </p:stCondLst>
                                         </p:cTn>
                                         <p:tgtEl>
-                                          <p:spTgt spid="14"/>
+                                          <p:spTgt spid="16"/>
                                         </p:tgtEl>
                                         <p:attrNameLst>
                                           <p:attrName>style.visibility</p:attrName>
@@ -5501,7 +5687,7 @@
                                       <p:cBhvr>
                                         <p:cTn id="34" dur="650"/>
                                         <p:tgtEl>
-                                          <p:spTgt spid="14"/>
+                                          <p:spTgt spid="16"/>
                                         </p:tgtEl>
                                       </p:cBhvr>
                                     </p:animEffect>
@@ -5514,7 +5700,7 @@
                         <p:par>
                           <p:cTn id="35" fill="hold">
                             <p:stCondLst>
-                              <p:cond delay="3370"/>
+                              <p:cond delay="2412"/>
                             </p:stCondLst>
                             <p:childTnLst>
                               <p:par>
@@ -5531,7 +5717,7 @@
                                           </p:stCondLst>
                                         </p:cTn>
                                         <p:tgtEl>
-                                          <p:spTgt spid="16"/>
+                                          <p:spTgt spid="14"/>
                                         </p:tgtEl>
                                         <p:attrNameLst>
                                           <p:attrName>style.visibility</p:attrName>
@@ -5545,7 +5731,7 @@
                                       <p:cBhvr>
                                         <p:cTn id="37" dur="650"/>
                                         <p:tgtEl>
-                                          <p:spTgt spid="16"/>
+                                          <p:spTgt spid="14"/>
                                         </p:tgtEl>
                                       </p:cBhvr>
                                     </p:animEffect>
@@ -5558,7 +5744,7 @@
                         <p:par>
                           <p:cTn id="38" fill="hold">
                             <p:stCondLst>
-                              <p:cond delay="3469"/>
+                              <p:cond delay="2537"/>
                             </p:stCondLst>
                             <p:childTnLst>
                               <p:par>
@@ -5602,7 +5788,7 @@
                         <p:par>
                           <p:cTn id="41" fill="hold">
                             <p:stCondLst>
-                              <p:cond delay="4163"/>
+                              <p:cond delay="3243"/>
                             </p:stCondLst>
                             <p:childTnLst>
                               <p:par>
@@ -5646,7 +5832,7 @@
                         <p:par>
                           <p:cTn id="44" fill="hold">
                             <p:stCondLst>
-                              <p:cond delay="4262"/>
+                              <p:cond delay="3368"/>
                             </p:stCondLst>
                             <p:childTnLst>
                               <p:par>
@@ -5714,15 +5900,15 @@
     <p:bldLst>
       <p:bldP spid="2" grpId="0"/>
       <p:bldP spid="4" grpId="0"/>
+      <p:bldP spid="5" grpId="0"/>
       <p:bldP spid="7" grpId="0"/>
-      <p:bldP spid="5" grpId="0"/>
+      <p:bldP spid="10" grpId="0"/>
+      <p:bldP spid="11" grpId="0"/>
       <p:bldP spid="8" grpId="0"/>
-      <p:bldP spid="10" grpId="0"/>
       <p:bldP spid="13" grpId="0"/>
       <p:bldP spid="3" grpId="0"/>
-      <p:bldP spid="11" grpId="0"/>
+      <p:bldP spid="16" grpId="0"/>
       <p:bldP spid="14" grpId="0"/>
-      <p:bldP spid="16" grpId="0"/>
       <p:bldP spid="18" grpId="0"/>
       <p:bldP spid="17" grpId="0"/>
       <p:bldP spid="19" grpId="0"/>
@@ -6076,50 +6262,6 @@
                             </p:stCondLst>
                             <p:childTnLst>
                               <p:par>
-                                <p:cTn presetID="10" presetClass="entr" presetSubtype="0" fill="hold" grpId="0" nodeType="afterEffect">
-                                  <p:stCondLst>
-                                    <p:cond delay="0"/>
-                                  </p:stCondLst>
-                                  <p:childTnLst>
-                                    <p:set>
-                                      <p:cBhvr>
-                                        <p:cTn id="8" dur="1" fill="hold">
-                                          <p:stCondLst>
-                                            <p:cond delay="0"/>
-                                          </p:stCondLst>
-                                        </p:cTn>
-                                        <p:tgtEl>
-                                          <p:spTgt spid="4"/>
-                                        </p:tgtEl>
-                                        <p:attrNameLst>
-                                          <p:attrName>style.visibility</p:attrName>
-                                        </p:attrNameLst>
-                                      </p:cBhvr>
-                                      <p:to>
-                                        <p:strVal val="visible"/>
-                                      </p:to>
-                                    </p:set>
-                                    <p:animEffect transition="in" filter="fade">
-                                      <p:cBhvr>
-                                        <p:cTn id="9" dur="790"/>
-                                        <p:tgtEl>
-                                          <p:spTgt spid="4"/>
-                                        </p:tgtEl>
-                                      </p:cBhvr>
-                                    </p:animEffect>
-                                  </p:childTnLst>
-                                </p:cTn>
-                              </p:par>
-                            </p:childTnLst>
-                          </p:cTn>
-                        </p:par>
-                        <p:par>
-                          <p:cTn id="10" fill="hold">
-                            <p:stCondLst>
-                              <p:cond delay="940"/>
-                            </p:stCondLst>
-                            <p:childTnLst>
-                              <p:par>
                                 <p:cTn presetID="23" presetClass="entr" presetSubtype="16" fill="hold" grpId="0" nodeType="afterEffect">
                                   <p:stCondLst>
                                     <p:cond delay="0"/>
@@ -6127,7 +6269,7 @@
                                   <p:childTnLst>
                                     <p:set>
                                       <p:cBhvr>
-                                        <p:cTn id="11" dur="1" fill="hold">
+                                        <p:cTn id="8" dur="1" fill="hold">
                                           <p:stCondLst>
                                             <p:cond delay="0"/>
                                           </p:stCondLst>
@@ -6145,7 +6287,7 @@
                                     </p:set>
                                     <p:animEffect transition="in" filter="fade">
                                       <p:cBhvr>
-                                        <p:cTn id="12" dur="790"/>
+                                        <p:cTn id="9" dur="790"/>
                                         <p:tgtEl>
                                           <p:spTgt spid="5"/>
                                         </p:tgtEl>
@@ -6153,7 +6295,7 @@
                                     </p:animEffect>
                                     <p:animScale>
                                       <p:cBhvr>
-                                        <p:cTn id="13" dur="790"/>
+                                        <p:cTn id="10" dur="790"/>
                                         <p:tgtEl>
                                           <p:spTgt spid="5"/>
                                         </p:tgtEl>
@@ -6168,9 +6310,9 @@
                           </p:cTn>
                         </p:par>
                         <p:par>
-                          <p:cTn id="14" fill="hold">
+                          <p:cTn id="11" fill="hold">
                             <p:stCondLst>
-                              <p:cond delay="1680"/>
+                              <p:cond delay="400"/>
                             </p:stCondLst>
                             <p:childTnLst>
                               <p:par>
@@ -6181,13 +6323,57 @@
                                   <p:childTnLst>
                                     <p:set>
                                       <p:cBhvr>
+                                        <p:cTn id="12" dur="1" fill="hold">
+                                          <p:stCondLst>
+                                            <p:cond delay="0"/>
+                                          </p:stCondLst>
+                                        </p:cTn>
+                                        <p:tgtEl>
+                                          <p:spTgt spid="4"/>
+                                        </p:tgtEl>
+                                        <p:attrNameLst>
+                                          <p:attrName>style.visibility</p:attrName>
+                                        </p:attrNameLst>
+                                      </p:cBhvr>
+                                      <p:to>
+                                        <p:strVal val="visible"/>
+                                      </p:to>
+                                    </p:set>
+                                    <p:animEffect transition="in" filter="fade">
+                                      <p:cBhvr>
+                                        <p:cTn id="13" dur="790"/>
+                                        <p:tgtEl>
+                                          <p:spTgt spid="4"/>
+                                        </p:tgtEl>
+                                      </p:cBhvr>
+                                    </p:animEffect>
+                                  </p:childTnLst>
+                                </p:cTn>
+                              </p:par>
+                            </p:childTnLst>
+                          </p:cTn>
+                        </p:par>
+                        <p:par>
+                          <p:cTn id="14" fill="hold">
+                            <p:stCondLst>
+                              <p:cond delay="600"/>
+                            </p:stCondLst>
+                            <p:childTnLst>
+                              <p:par>
+                                <p:cTn presetID="10" presetClass="entr" presetSubtype="0" fill="hold" grpId="0" nodeType="afterEffect">
+                                  <p:stCondLst>
+                                    <p:cond delay="0"/>
+                                  </p:stCondLst>
+                                  <p:childTnLst>
+                                    <p:set>
+                                      <p:cBhvr>
                                         <p:cTn id="15" dur="1" fill="hold">
                                           <p:stCondLst>
                                             <p:cond delay="0"/>
                                           </p:stCondLst>
                                         </p:cTn>
                                         <p:tgtEl>
-                                          <p:spTgt spid="6"/>
+                                          <p:spTgt spid="4"/>
                                         </p:tgtEl>
                                         <p:attrNameLst>
                                           <p:attrName>style.visibility</p:attrName>
@@ -6200,6 +6386,50 @@
                                     <p:animEffect transition="in" filter="fade">
                                       <p:cBhvr>
                                         <p:cTn id="16" dur="650"/>
+                                        <p:tgtEl>
+                                          <p:spTgt spid="4"/>
+                                        </p:tgtEl>
+                                      </p:cBhvr>
+                                    </p:animEffect>
+                                  </p:childTnLst>
+                                </p:cTn>
+                              </p:par>
+                            </p:childTnLst>
+                          </p:cTn>
+                        </p:par>
+                        <p:par>
+                          <p:cTn id="17" fill="hold">
+                            <p:stCondLst>
+                              <p:cond delay="1340"/>
+                            </p:stCondLst>
+                            <p:childTnLst>
+                              <p:par>
+                                <p:cTn presetID="10" presetClass="entr" presetSubtype="0" fill="hold" grpId="0" nodeType="afterEffect">
+                                  <p:stCondLst>
+                                    <p:cond delay="0"/>
+                                  </p:stCondLst>
+                                  <p:childTnLst>
+                                    <p:set>
+                                      <p:cBhvr>
+                                        <p:cTn id="18" dur="1" fill="hold">
+                                          <p:stCondLst>
+                                            <p:cond delay="0"/>
+                                          </p:stCondLst>
+                                        </p:cTn>
+                                        <p:tgtEl>
+                                          <p:spTgt spid="6"/>
+                                        </p:tgtEl>
+                                        <p:attrNameLst>
+                                          <p:attrName>style.visibility</p:attrName>
+                                        </p:attrNameLst>
+                                      </p:cBhvr>
+                                      <p:to>
+                                        <p:strVal val="visible"/>
+                                      </p:to>
+                                    </p:set>
+                                    <p:animEffect transition="in" filter="fade">
+                                      <p:cBhvr>
+                                        <p:cTn id="19" dur="650"/>
                                         <p:tgtEl>
                                           <p:spTgt spid="6"/>
                                         </p:tgtEl>
@@ -6237,8 +6467,8 @@
     </p:tnLst>
     <p:bldLst>
       <p:bldP spid="3" grpId="0"/>
+      <p:bldP spid="5" grpId="0"/>
       <p:bldP spid="4" grpId="0"/>
-      <p:bldP spid="5" grpId="0"/>
       <p:bldP spid="6" grpId="0"/>
     </p:bldLst>
   </p:timing>
@@ -6692,7 +6922,7 @@
                                           </p:stCondLst>
                                         </p:cTn>
                                         <p:tgtEl>
-                                          <p:spTgt spid="3"/>
+                                          <p:spTgt spid="5"/>
                                         </p:tgtEl>
                                         <p:attrNameLst>
                                           <p:attrName>style.visibility</p:attrName>
@@ -6706,7 +6936,7 @@
                                       <p:cBhvr>
                                         <p:cTn id="9" dur="650"/>
                                         <p:tgtEl>
-                                          <p:spTgt spid="3"/>
+                                          <p:spTgt spid="5"/>
                                         </p:tgtEl>
                                       </p:cBhvr>
                                     </p:animEffect>
@@ -6719,7 +6949,7 @@
                         <p:par>
                           <p:cTn id="10" fill="hold">
                             <p:stCondLst>
-                              <p:cond delay="940"/>
+                              <p:cond delay="400"/>
                             </p:stCondLst>
                             <p:childTnLst>
                               <p:par>
@@ -6736,7 +6966,7 @@
                                           </p:stCondLst>
                                         </p:cTn>
                                         <p:tgtEl>
-                                          <p:spTgt spid="5"/>
+                                          <p:spTgt spid="3"/>
                                         </p:tgtEl>
                                         <p:attrNameLst>
                                           <p:attrName>style.visibility</p:attrName>
@@ -6750,7 +6980,7 @@
                                       <p:cBhvr>
                                         <p:cTn id="12" dur="650"/>
                                         <p:tgtEl>
-                                          <p:spTgt spid="5"/>
+                                          <p:spTgt spid="3"/>
                                         </p:tgtEl>
                                       </p:cBhvr>
                                     </p:animEffect>
@@ -6763,7 +6993,7 @@
                         <p:par>
                           <p:cTn id="13" fill="hold">
                             <p:stCondLst>
-                              <p:cond delay="1140"/>
+                              <p:cond delay="600"/>
                             </p:stCondLst>
                             <p:childTnLst>
                               <p:par>
@@ -6807,7 +7037,7 @@
                         <p:par>
                           <p:cTn id="16" fill="hold">
                             <p:stCondLst>
-                              <p:cond delay="1880"/>
+                              <p:cond delay="1340"/>
                             </p:stCondLst>
                             <p:childTnLst>
                               <p:par>
@@ -6851,7 +7081,7 @@
                         <p:par>
                           <p:cTn id="19" fill="hold">
                             <p:stCondLst>
-                              <p:cond delay="2080"/>
+                              <p:cond delay="1540"/>
                             </p:stCondLst>
                             <p:childTnLst>
                               <p:par>
@@ -6918,8 +7148,8 @@
     </p:tnLst>
     <p:bldLst>
       <p:bldP spid="2" grpId="0"/>
+      <p:bldP spid="5" grpId="0"/>
       <p:bldP spid="3" grpId="0"/>
-      <p:bldP spid="5" grpId="0"/>
       <p:bldP spid="6" grpId="0"/>
       <p:bldP spid="8" grpId="0"/>
       <p:bldP spid="9" grpId="0"/>

</xml_diff>